<commit_message>
Raise novelty of the YatraDrishti idea deck
Rebuilds the core around five new mechanisms: a per-hotel WhatsApp AI
front desk on the existing multi-tenant gateway, a Tourism Demand
Exchange where nearby hotels bid for forecast overflow, a capacity
guard that keeps every twin under 80%, a destination-only credit wallet,
and an AI micro-package composer with UPI split settlement. Flowchart,
feasibility risks, impact and references updated to match.

Co-Authored-By: Claude Opus 5.5 <noreply@anthropic.com>
Claude-Session: https://claude.ai/code/session_01TzsZ73zrP5mNPRwfMYNJ7z
</commit_message>
<xml_diff>
--- a/SIH_Submission/YatraDrishti_SIH_Idea_Presentation.pptx
+++ b/SIH_Submission/YatraDrishti_SIH_Idea_Presentation.pptx
@@ -6342,7 +6342,7 @@
                 </a:solidFill>
                 <a:latin typeface="Arial"/>
               </a:rPr>
-              <a:t>is a multi-sided AI platform that unites </a:t>
+              <a:t>turns every small hotel's WhatsApp into an </a:t>
             </a:r>
             <a:r>
               <a:rPr sz="1200" b="1" i="0">
@@ -6351,7 +6351,7 @@
                 </a:solidFill>
                 <a:latin typeface="Arial"/>
               </a:rPr>
-              <a:t>tourists, hoteliers, transport providers and local artisans</a:t>
+              <a:t>AI front desk</a:t>
             </a:r>
             <a:r>
               <a:rPr sz="1200" b="0" i="0">
@@ -6360,7 +6360,25 @@
                 </a:solidFill>
                 <a:latin typeface="Arial"/>
               </a:rPr>
-              <a:t> in one intelligent ecosystem: a Sustainable Tourism Operating System that links demand for hotels with predictive crowd balancing for governments.</a:t>
+              <a:t> and links them in a live </a:t>
+            </a:r>
+            <a:r>
+              <a:rPr sz="1200" b="1" i="0">
+                <a:solidFill>
+                  <a:srgbClr val="E87722"/>
+                </a:solidFill>
+                <a:latin typeface="Arial"/>
+              </a:rPr>
+              <a:t>Tourism Demand Exchange</a:t>
+            </a:r>
+            <a:r>
+              <a:rPr sz="1200" b="0" i="0">
+                <a:solidFill>
+                  <a:srgbClr val="1C2733"/>
+                </a:solidFill>
+                <a:latin typeface="Arial"/>
+              </a:rPr>
+              <a:t>: before a hotspot overflows, nearby hotels bid for the surplus tourists within safe capacity, and credits keep the money in the local economy.</a:t>
             </a:r>
           </a:p>
         </p:txBody>
@@ -6382,7 +6400,7 @@
             </a:avLst>
           </a:prstGeom>
           <a:solidFill>
-            <a:srgbClr val="EAF1FB"/>
+            <a:srgbClr val="E6F4EC"/>
           </a:solidFill>
           <a:ln>
             <a:noFill/>
@@ -6426,7 +6444,7 @@
             <a:avLst/>
           </a:prstGeom>
           <a:solidFill>
-            <a:srgbClr val="0070C0"/>
+            <a:srgbClr val="2E8B57"/>
           </a:solidFill>
           <a:ln>
             <a:noFill/>
@@ -6457,7 +6475,7 @@
       </p:sp>
       <p:pic>
         <p:nvPicPr>
-          <p:cNvPr id="15367" name="Picture 15366" descr="robot.png"/>
+          <p:cNvPr id="15367" name="Picture 15366" descr="whatsapp.png"/>
           <p:cNvPicPr>
             <a:picLocks noChangeAspect="1"/>
           </p:cNvPicPr>
@@ -6509,11 +6527,11 @@
             <a:r>
               <a:rPr sz="1100" b="1" i="0">
                 <a:solidFill>
-                  <a:srgbClr val="0070C0"/>
-                </a:solidFill>
-                <a:latin typeface="Arial"/>
-              </a:rPr>
-              <a:t>1  Tourist App</a:t>
+                  <a:srgbClr val="2E8B57"/>
+                </a:solidFill>
+                <a:latin typeface="Arial"/>
+              </a:rPr>
+              <a:t>1  AI Front Desk</a:t>
             </a:r>
           </a:p>
         </p:txBody>
@@ -6552,7 +6570,7 @@
                 </a:solidFill>
                 <a:latin typeface="Arial"/>
               </a:rPr>
-              <a:t>GenAI itinerary (budget, pace, weather) · AR monument overlay · Green Travel Pass</a:t>
+              <a:t>Each hotel gets its own multilingual WhatsApp AI that answers, books &amp; upsells; no app</a:t>
             </a:r>
           </a:p>
         </p:txBody>
@@ -6693,7 +6711,7 @@
       </p:sp>
       <p:pic>
         <p:nvPicPr>
-          <p:cNvPr id="15373" name="Picture 15372" descr="hotel.png"/>
+          <p:cNvPr id="15373" name="Picture 15372" descr="balance.png"/>
           <p:cNvPicPr>
             <a:picLocks noChangeAspect="1"/>
           </p:cNvPicPr>
@@ -6749,7 +6767,7 @@
                 </a:solidFill>
                 <a:latin typeface="Arial"/>
               </a:rPr>
-              <a:t>2  Hotelier Suite</a:t>
+              <a:t>2  Demand Exchange</a:t>
             </a:r>
           </a:p>
         </p:txBody>
@@ -6788,7 +6806,7 @@
                 </a:solidFill>
                 <a:latin typeface="Arial"/>
               </a:rPr>
-              <a:t>XGBoost + Prophet dynamic pricing · zero-commission direct booking</a:t>
+              <a:t>Forecast overflow is offered to nearby hotels; they bid discounts in one tap</a:t>
             </a:r>
           </a:p>
         </p:txBody>
@@ -6854,7 +6872,7 @@
             </a:avLst>
           </a:prstGeom>
           <a:solidFill>
-            <a:srgbClr val="E6F4EC"/>
+            <a:srgbClr val="FBEAEA"/>
           </a:solidFill>
           <a:ln>
             <a:noFill/>
@@ -6898,7 +6916,7 @@
             <a:avLst/>
           </a:prstGeom>
           <a:solidFill>
-            <a:srgbClr val="2E8B57"/>
+            <a:srgbClr val="D64545"/>
           </a:solidFill>
           <a:ln>
             <a:noFill/>
@@ -6929,7 +6947,7 @@
       </p:sp>
       <p:pic>
         <p:nvPicPr>
-          <p:cNvPr id="15379" name="Picture 15378" descr="balance.png"/>
+          <p:cNvPr id="15379" name="Picture 15378" descr="kavach.png"/>
           <p:cNvPicPr>
             <a:picLocks noChangeAspect="1"/>
           </p:cNvPicPr>
@@ -6981,11 +6999,11 @@
             <a:r>
               <a:rPr sz="1100" b="1" i="0">
                 <a:solidFill>
-                  <a:srgbClr val="2E8B57"/>
-                </a:solidFill>
-                <a:latin typeface="Arial"/>
-              </a:rPr>
-              <a:t>3  Overtourism Mitigator</a:t>
+                  <a:srgbClr val="D64545"/>
+                </a:solidFill>
+                <a:latin typeface="Arial"/>
+              </a:rPr>
+              <a:t>3  Capacity Guard</a:t>
             </a:r>
           </a:p>
         </p:txBody>
@@ -7024,7 +7042,7 @@
                 </a:solidFill>
                 <a:latin typeface="Arial"/>
               </a:rPr>
-              <a:t>Predicts crowd peaks · nudges to time-shifted or hidden spots with credits</a:t>
+              <a:t>Live carrying-capacity index; no twin pushed above 80%, so no new hotspot</a:t>
             </a:r>
           </a:p>
         </p:txBody>
@@ -7090,7 +7108,7 @@
             </a:avLst>
           </a:prstGeom>
           <a:solidFill>
-            <a:srgbClr val="F1EBF8"/>
+            <a:srgbClr val="EAF1FB"/>
           </a:solidFill>
           <a:ln>
             <a:noFill/>
@@ -7134,7 +7152,7 @@
             <a:avLst/>
           </a:prstGeom>
           <a:solidFill>
-            <a:srgbClr val="6A3D9A"/>
+            <a:srgbClr val="0070C0"/>
           </a:solidFill>
           <a:ln>
             <a:noFill/>
@@ -7165,7 +7183,7 @@
       </p:sp>
       <p:pic>
         <p:nvPicPr>
-          <p:cNvPr id="15385" name="Picture 15384" descr="store.png"/>
+          <p:cNvPr id="15385" name="Picture 15384" descr="economic.png"/>
           <p:cNvPicPr>
             <a:picLocks noChangeAspect="1"/>
           </p:cNvPicPr>
@@ -7217,11 +7235,11 @@
             <a:r>
               <a:rPr sz="1100" b="1" i="0">
                 <a:solidFill>
-                  <a:srgbClr val="6A3D9A"/>
-                </a:solidFill>
-                <a:latin typeface="Arial"/>
-              </a:rPr>
-              <a:t>4  Local Vendor Hub</a:t>
+                  <a:srgbClr val="0070C0"/>
+                </a:solidFill>
+                <a:latin typeface="Arial"/>
+              </a:rPr>
+              <a:t>4  Destination Wallet</a:t>
             </a:r>
           </a:p>
         </p:txBody>
@@ -7260,7 +7278,7 @@
                 </a:solidFill>
                 <a:latin typeface="Arial"/>
               </a:rPr>
-              <a:t>One-click, QR-verified onboarding of guides, artisans &amp; homestays</a:t>
+              <a:t>Green Travel Credits spendable only at local MSMEs; geo-fenced 2-way QR</a:t>
             </a:r>
           </a:p>
         </p:txBody>
@@ -7326,7 +7344,7 @@
             </a:avLst>
           </a:prstGeom>
           <a:solidFill>
-            <a:srgbClr val="FBEAEA"/>
+            <a:srgbClr val="F1EBF8"/>
           </a:solidFill>
           <a:ln>
             <a:noFill/>
@@ -7370,7 +7388,7 @@
             <a:avLst/>
           </a:prstGeom>
           <a:solidFill>
-            <a:srgbClr val="D64545"/>
+            <a:srgbClr val="6A3D9A"/>
           </a:solidFill>
           <a:ln>
             <a:noFill/>
@@ -7401,7 +7419,7 @@
       </p:sp>
       <p:pic>
         <p:nvPicPr>
-          <p:cNvPr id="15391" name="Picture 15390" descr="mobile.png"/>
+          <p:cNvPr id="15391" name="Picture 15390" descr="store.png"/>
           <p:cNvPicPr>
             <a:picLocks noChangeAspect="1"/>
           </p:cNvPicPr>
@@ -7453,11 +7471,11 @@
             <a:r>
               <a:rPr sz="1100" b="1" i="0">
                 <a:solidFill>
-                  <a:srgbClr val="D64545"/>
-                </a:solidFill>
-                <a:latin typeface="Arial"/>
-              </a:rPr>
-              <a:t>5  Offline Edge-AI Guide</a:t>
+                  <a:srgbClr val="6A3D9A"/>
+                </a:solidFill>
+                <a:latin typeface="Arial"/>
+              </a:rPr>
+              <a:t>5  Micro-Package Composer</a:t>
             </a:r>
           </a:p>
         </p:txBody>
@@ -7496,7 +7514,7 @@
                 </a:solidFill>
                 <a:latin typeface="Arial"/>
               </a:rPr>
-              <a:t>On-device multilingual voice guide, translation &amp; SOS without network</a:t>
+              <a:t>AI bundles homestay + guide + artisan + cab into one booking; auto UPI split</a:t>
             </a:r>
           </a:p>
         </p:txBody>
@@ -7608,7 +7626,7 @@
                 </a:solidFill>
                 <a:latin typeface="Arial"/>
               </a:rPr>
-              <a:t>Overcrowded tier-1 hotspots</a:t>
+              <a:t>Overcrowded hotspots</a:t>
             </a:r>
             <a:r>
               <a:rPr sz="1200" b="0" i="0">
@@ -7626,7 +7644,7 @@
                 </a:solidFill>
                 <a:latin typeface="Arial"/>
               </a:rPr>
-              <a:t>predictive, time-shifted rerouting</a:t>
+              <a:t>overflow auctioned to nearby hotels in advance</a:t>
             </a:r>
           </a:p>
           <a:p>
@@ -7665,7 +7683,7 @@
                 </a:solidFill>
                 <a:latin typeface="Arial"/>
               </a:rPr>
-              <a:t>zero-commission direct booking engine</a:t>
+              <a:t>direct bookings via the hotel's own AI WhatsApp</a:t>
             </a:r>
           </a:p>
           <a:p>
@@ -7686,7 +7704,7 @@
                 </a:solidFill>
                 <a:latin typeface="Arial"/>
               </a:rPr>
-              <a:t>Guesswork hotel pricing</a:t>
+              <a:t>No live crowd data</a:t>
             </a:r>
             <a:r>
               <a:rPr sz="1200" b="0" i="0">
@@ -7704,7 +7722,7 @@
                 </a:solidFill>
                 <a:latin typeface="Arial"/>
               </a:rPr>
-              <a:t>AI demand forecast &amp; dynamic rates</a:t>
+              <a:t>1-tap WhatsApp pulses from hotels &amp; vendors</a:t>
             </a:r>
           </a:p>
           <a:p>
@@ -7743,7 +7761,7 @@
                 </a:solidFill>
                 <a:latin typeface="Arial"/>
               </a:rPr>
-              <a:t>verified marketplace inside itineraries</a:t>
+              <a:t>bundled into AI micro-packages</a:t>
             </a:r>
           </a:p>
           <a:p>
@@ -7764,7 +7782,7 @@
                 </a:solidFill>
                 <a:latin typeface="Arial"/>
               </a:rPr>
-              <a:t>Static, unsafe itineraries</a:t>
+              <a:t>Tourist money leaks out</a:t>
             </a:r>
             <a:r>
               <a:rPr sz="1200" b="0" i="0">
@@ -7782,7 +7800,7 @@
                 </a:solidFill>
                 <a:latin typeface="Arial"/>
               </a:rPr>
-              <a:t>weather-aware plans + offline SOS</a:t>
+              <a:t>credits recirculate inside the destination</a:t>
             </a:r>
           </a:p>
         </p:txBody>
@@ -7894,7 +7912,7 @@
                 </a:solidFill>
                 <a:latin typeface="Arial"/>
               </a:rPr>
-              <a:t>Tourism OS: </a:t>
+              <a:t>Self-funding crowd balancing: </a:t>
             </a:r>
             <a:r>
               <a:rPr sz="1200" b="0" i="0">
@@ -7903,7 +7921,7 @@
                 </a:solidFill>
                 <a:latin typeface="Arial"/>
               </a:rPr>
-              <a:t>tourist actions update hotel &amp; vendor analytics live</a:t>
+              <a:t>hotels bid for diverted tourists</a:t>
             </a:r>
           </a:p>
           <a:p>
@@ -7924,7 +7942,7 @@
                 </a:solidFill>
                 <a:latin typeface="Arial"/>
               </a:rPr>
-              <a:t>Green Travel Credits: </a:t>
+              <a:t>Hotel-in-a-WhatsApp: </a:t>
             </a:r>
             <a:r>
               <a:rPr sz="1200" b="0" i="0">
@@ -7933,7 +7951,7 @@
                 </a:solidFill>
                 <a:latin typeface="Arial"/>
               </a:rPr>
-              <a:t>crowd pressure becomes revenue for nearby spots</a:t>
+              <a:t>multi-tenant AI front desk, already prototyped</a:t>
             </a:r>
           </a:p>
           <a:p>
@@ -7954,7 +7972,7 @@
                 </a:solidFill>
                 <a:latin typeface="Arial"/>
               </a:rPr>
-              <a:t>Enterprise AI for small hotels: </a:t>
+              <a:t>Human sensor network: </a:t>
             </a:r>
             <a:r>
               <a:rPr sz="1200" b="0" i="0">
@@ -7963,7 +7981,7 @@
                 </a:solidFill>
                 <a:latin typeface="Arial"/>
               </a:rPr>
-              <a:t>5-minute setup via WhatsApp or iCal</a:t>
+              <a:t>MSME pulses replace tourist tracking</a:t>
             </a:r>
           </a:p>
           <a:p>
@@ -7984,7 +8002,7 @@
                 </a:solidFill>
                 <a:latin typeface="Arial"/>
               </a:rPr>
-              <a:t>Offline Edge-AI: </a:t>
+              <a:t>Closed-loop local money: </a:t>
             </a:r>
             <a:r>
               <a:rPr sz="1200" b="0" i="0">
@@ -7993,7 +8011,7 @@
                 </a:solidFill>
                 <a:latin typeface="Arial"/>
               </a:rPr>
-              <a:t>safety guide works in no-network regions</a:t>
+              <a:t>credits spendable only in the destination</a:t>
             </a:r>
           </a:p>
           <a:p>
@@ -8014,7 +8032,7 @@
                 </a:solidFill>
                 <a:latin typeface="Arial"/>
               </a:rPr>
-              <a:t>Not an aggregator or GPT wrapper: </a:t>
+              <a:t>No overflow cascade: </a:t>
             </a:r>
             <a:r>
               <a:rPr sz="1200" b="0" i="0">
@@ -8023,7 +8041,7 @@
                 </a:solidFill>
                 <a:latin typeface="Arial"/>
               </a:rPr>
-              <a:t>real pricing models + spatial analytics</a:t>
+              <a:t>capacity guard keeps every twin under 80%</a:t>
             </a:r>
           </a:p>
         </p:txBody>
@@ -8621,6 +8639,15 @@
                         </a:rPr>
                         <a:t>(already built)</a:t>
                       </a:r>
+                      <a:r>
+                        <a:rPr sz="1000" b="0" i="0">
+                          <a:solidFill>
+                            <a:srgbClr val="1C2733"/>
+                          </a:solidFill>
+                          <a:latin typeface="Arial"/>
+                        </a:rPr>
+                        <a:t> → per-hotel AI desk</a:t>
+                      </a:r>
                     </a:p>
                   </a:txBody>
                   <a:tcPr marL="73152" marR="73152" marT="27432" marB="27432" anchor="ctr">
@@ -8675,7 +8702,7 @@
                           </a:solidFill>
                           <a:latin typeface="Arial"/>
                         </a:rPr>
-                        <a:t>XGBoost + Prophet · PyTorch · LangChain + Llama-3 / Gemini</a:t>
+                        <a:t>XGBoost + Prophet · LangChain + Llama-3 / Gemini</a:t>
                       </a:r>
                     </a:p>
                   </a:txBody>
@@ -8704,7 +8731,7 @@
                           </a:solidFill>
                           <a:latin typeface="Arial"/>
                         </a:rPr>
-                        <a:t>Data</a:t>
+                        <a:t>Matching</a:t>
                       </a:r>
                     </a:p>
                   </a:txBody>
@@ -8731,7 +8758,7 @@
                           </a:solidFill>
                           <a:latin typeface="Arial"/>
                         </a:rPr>
-                        <a:t>PostgreSQL + PostGIS · Redis · H3 hexagon grid</a:t>
+                        <a:t>OR-Tools: bid matching under capacity limits</a:t>
                       </a:r>
                     </a:p>
                   </a:txBody>
@@ -8760,7 +8787,7 @@
                           </a:solidFill>
                           <a:latin typeface="Arial"/>
                         </a:rPr>
-                        <a:t>AR / Edge</a:t>
+                        <a:t>Data</a:t>
                       </a:r>
                     </a:p>
                   </a:txBody>
@@ -8787,7 +8814,7 @@
                           </a:solidFill>
                           <a:latin typeface="Arial"/>
                         </a:rPr>
-                        <a:t>ARCore / ARKit · TensorFlow Lite (on-device)</a:t>
+                        <a:t>PostgreSQL + PostGIS · Redis · H3 · Docker / K8s</a:t>
                       </a:r>
                     </a:p>
                   </a:txBody>
@@ -8816,7 +8843,7 @@
                           </a:solidFill>
                           <a:latin typeface="Arial"/>
                         </a:rPr>
-                        <a:t>APIs</a:t>
+                        <a:t>Payments</a:t>
                       </a:r>
                     </a:p>
                   </a:txBody>
@@ -8843,7 +8870,7 @@
                           </a:solidFill>
                           <a:latin typeface="Arial"/>
                         </a:rPr>
-                        <a:t>OpenStreetMap · OpenWeatherMap · data.tourism.gov.in · Razorpay (test)</a:t>
+                        <a:t>UPI split settlement (Razorpay Route, test mode)</a:t>
                       </a:r>
                     </a:p>
                   </a:txBody>
@@ -8872,7 +8899,7 @@
                           </a:solidFill>
                           <a:latin typeface="Arial"/>
                         </a:rPr>
-                        <a:t>Cloud</a:t>
+                        <a:t>Tourist UX</a:t>
                       </a:r>
                     </a:p>
                   </a:txBody>
@@ -8899,7 +8926,7 @@
                           </a:solidFill>
                           <a:latin typeface="Arial"/>
                         </a:rPr>
-                        <a:t>Docker · Kubernetes · AWS / GCP</a:t>
+                        <a:t>AR (ARCore / ARKit) · TensorFlow Lite offline guide</a:t>
                       </a:r>
                     </a:p>
                   </a:txBody>
@@ -9094,7 +9121,7 @@
                 </a:solidFill>
                 <a:latin typeface="Arial"/>
               </a:rPr>
-              <a:t>Tourist preferences</a:t>
+              <a:t>Bookings / iCal</a:t>
             </a:r>
           </a:p>
         </p:txBody>
@@ -9155,7 +9182,7 @@
                 </a:solidFill>
                 <a:latin typeface="Arial"/>
               </a:rPr>
-              <a:t>Bookings / iCal</a:t>
+              <a:t>MSME WhatsApp pulses</a:t>
             </a:r>
           </a:p>
         </p:txBody>
@@ -9338,7 +9365,7 @@
                 </a:solidFill>
                 <a:latin typeface="Arial"/>
               </a:rPr>
-              <a:t>Local events</a:t>
+              <a:t>Events &amp; holidays</a:t>
             </a:r>
           </a:p>
         </p:txBody>
@@ -9679,7 +9706,7 @@
                 </a:solidFill>
                 <a:latin typeface="Arial"/>
               </a:rPr>
-              <a:t>3  Crowd density</a:t>
+              <a:t>3  Capacity guard</a:t>
             </a:r>
           </a:p>
           <a:p>
@@ -9695,7 +9722,7 @@
                 </a:solidFill>
                 <a:latin typeface="Arial"/>
               </a:rPr>
-              <a:t>anonymised H3 grid</a:t>
+              <a:t>live index per site</a:t>
             </a:r>
           </a:p>
         </p:txBody>
@@ -9798,7 +9825,7 @@
                 </a:solidFill>
                 <a:latin typeface="Arial"/>
               </a:rPr>
-              <a:t>4  Peak ahead?</a:t>
+              <a:t>4  Overflow ahead?</a:t>
             </a:r>
           </a:p>
           <a:p>
@@ -9814,7 +9841,7 @@
                 </a:solidFill>
                 <a:latin typeface="Arial"/>
               </a:rPr>
-              <a:t>per site, per hour</a:t>
+              <a:t>demand &gt; 80% capacity</a:t>
             </a:r>
           </a:p>
         </p:txBody>
@@ -9919,7 +9946,7 @@
                 </a:solidFill>
                 <a:latin typeface="Arial"/>
               </a:rPr>
-              <a:t>YES: congestion</a:t>
+              <a:t>YES: overflow</a:t>
             </a:r>
           </a:p>
           <a:p>
@@ -10038,7 +10065,7 @@
                 </a:solidFill>
                 <a:latin typeface="Arial"/>
               </a:rPr>
-              <a:t>5  Rebalance: time-shifted or secondary-site nudge + Green Travel Credits; hotel rates re-optimised</a:t>
+              <a:t>5  Demand Exchange: surplus offered to nearby hotels on WhatsApp → best bids within capacity → tourist gets twin + credits</a:t>
             </a:r>
           </a:p>
         </p:txBody>
@@ -10143,7 +10170,7 @@
                 </a:solidFill>
                 <a:latin typeface="Arial"/>
               </a:rPr>
-              <a:t>Tourist app</a:t>
+              <a:t>Tourist app / WhatsApp</a:t>
             </a:r>
           </a:p>
           <a:p>
@@ -10159,7 +10186,7 @@
                 </a:solidFill>
                 <a:latin typeface="Arial"/>
               </a:rPr>
-              <a:t>itinerary · AR · credits · SOS</a:t>
+              <a:t>itinerary · packages · credits</a:t>
             </a:r>
           </a:p>
         </p:txBody>
@@ -10220,7 +10247,7 @@
                 </a:solidFill>
                 <a:latin typeface="Arial"/>
               </a:rPr>
-              <a:t>Hotel dashboard + WhatsApp</a:t>
+              <a:t>Hotel AI front desk</a:t>
             </a:r>
           </a:p>
           <a:p>
@@ -10236,7 +10263,7 @@
                 </a:solidFill>
                 <a:latin typeface="Arial"/>
               </a:rPr>
-              <a:t>rate alerts · direct bookings</a:t>
+              <a:t>bids · bookings · rate tips</a:t>
             </a:r>
           </a:p>
         </p:txBody>
@@ -10466,7 +10493,7 @@
                 </a:solidFill>
                 <a:latin typeface="Arial"/>
               </a:rPr>
-              <a:t>6–14 h  Pricing &amp; forecast</a:t>
+              <a:t>6–14 h  Forecast &amp; capacity</a:t>
             </a:r>
           </a:p>
         </p:txBody>
@@ -10523,7 +10550,7 @@
                 </a:solidFill>
                 <a:latin typeface="Arial"/>
               </a:rPr>
-              <a:t>14–22 h  Itinerary AI &amp; crowd</a:t>
+              <a:t>14–22 h  Demand Exchange</a:t>
             </a:r>
           </a:p>
         </p:txBody>
@@ -10580,7 +10607,7 @@
                 </a:solidFill>
                 <a:latin typeface="Arial"/>
               </a:rPr>
-              <a:t>22–30 h  Apps &amp; AR</a:t>
+              <a:t>22–30 h  AI desk &amp; wallet</a:t>
             </a:r>
           </a:p>
         </p:txBody>
@@ -11327,7 +11354,7 @@
                 </a:solidFill>
                 <a:latin typeface="Arial"/>
               </a:rPr>
-              <a:t>Multi-tenant WhatsApp AI gateway already working</a:t>
+              <a:t>WhatsApp AI gateway already works</a:t>
             </a:r>
           </a:p>
           <a:p>
@@ -11348,7 +11375,7 @@
                 </a:solidFill>
                 <a:latin typeface="Arial"/>
               </a:rPr>
-              <a:t>Per-tenant AI prompts defined</a:t>
+              <a:t>Per-hotel AI desk = new tenant config, not new code</a:t>
             </a:r>
           </a:p>
         </p:txBody>
@@ -11784,7 +11811,7 @@
                 </a:solidFill>
                 <a:latin typeface="Arial"/>
               </a:rPr>
-              <a:t>3–5% fee on local experiences</a:t>
+              <a:t>Small fee on Exchange wins &amp; packages</a:t>
             </a:r>
           </a:p>
         </p:txBody>
@@ -11981,7 +12008,7 @@
                 </a:solidFill>
                 <a:latin typeface="Arial"/>
               </a:rPr>
-              <a:t>5-minute hotel setup via WhatsApp / iCal</a:t>
+              <a:t>Nothing to install: hotels use WhatsApp</a:t>
             </a:r>
           </a:p>
           <a:p>
@@ -12002,7 +12029,7 @@
                 </a:solidFill>
                 <a:latin typeface="Arial"/>
               </a:rPr>
-              <a:t>Fits existing hotel PMS</a:t>
+              <a:t>Fits existing PMS via iCal</a:t>
             </a:r>
           </a:p>
         </p:txBody>
@@ -12281,7 +12308,7 @@
         </p:nvGraphicFramePr>
         <p:xfrm>
           <a:off x="365760" y="3593592"/>
-          <a:ext cx="11457432" cy="2496312"/>
+          <a:ext cx="11457432" cy="2596896"/>
         </p:xfrm>
         <a:graphic>
           <a:graphicData uri="http://schemas.openxmlformats.org/drawingml/2006/table">
@@ -12293,7 +12320,7 @@
                 <a:gridCol w="3566160"/>
                 <a:gridCol w="7891272"/>
               </a:tblGrid>
-              <a:tr h="356616">
+              <a:tr h="324612">
                 <a:tc>
                   <a:txBody>
                     <a:bodyPr wrap="square"/>
@@ -12305,7 +12332,7 @@
                         </a:spcAft>
                       </a:pPr>
                       <a:r>
-                        <a:rPr sz="1050" b="1" i="0">
+                        <a:rPr sz="1000" b="1" i="0">
                           <a:solidFill>
                             <a:srgbClr val="FFFFFF"/>
                           </a:solidFill>
@@ -12332,7 +12359,7 @@
                         </a:spcAft>
                       </a:pPr>
                       <a:r>
-                        <a:rPr sz="1050" b="1" i="0">
+                        <a:rPr sz="1000" b="1" i="0">
                           <a:solidFill>
                             <a:srgbClr val="FFFFFF"/>
                           </a:solidFill>
@@ -12349,7 +12376,7 @@
                   </a:tcPr>
                 </a:tc>
               </a:tr>
-              <a:tr h="356616">
+              <a:tr h="324612">
                 <a:tc>
                   <a:txBody>
                     <a:bodyPr wrap="square"/>
@@ -12361,7 +12388,7 @@
                         </a:spcAft>
                       </a:pPr>
                       <a:r>
-                        <a:rPr sz="1050" b="1" i="0">
+                        <a:rPr sz="1000" b="1" i="0">
                           <a:solidFill>
                             <a:srgbClr val="D64545"/>
                           </a:solidFill>
@@ -12388,7 +12415,7 @@
                         </a:spcAft>
                       </a:pPr>
                       <a:r>
-                        <a:rPr sz="1050" b="0" i="0">
+                        <a:rPr sz="1000" b="0" i="0">
                           <a:solidFill>
                             <a:srgbClr val="1C2733"/>
                           </a:solidFill>
@@ -12405,7 +12432,7 @@
                   </a:tcPr>
                 </a:tc>
               </a:tr>
-              <a:tr h="356616">
+              <a:tr h="324612">
                 <a:tc>
                   <a:txBody>
                     <a:bodyPr wrap="square"/>
@@ -12417,7 +12444,7 @@
                         </a:spcAft>
                       </a:pPr>
                       <a:r>
-                        <a:rPr sz="1050" b="1" i="0">
+                        <a:rPr sz="1000" b="1" i="0">
                           <a:solidFill>
                             <a:srgbClr val="D64545"/>
                           </a:solidFill>
@@ -12444,7 +12471,7 @@
                         </a:spcAft>
                       </a:pPr>
                       <a:r>
-                        <a:rPr sz="1050" b="0" i="0">
+                        <a:rPr sz="1000" b="0" i="0">
                           <a:solidFill>
                             <a:srgbClr val="1C2733"/>
                           </a:solidFill>
@@ -12461,7 +12488,7 @@
                   </a:tcPr>
                 </a:tc>
               </a:tr>
-              <a:tr h="356616">
+              <a:tr h="324612">
                 <a:tc>
                   <a:txBody>
                     <a:bodyPr wrap="square"/>
@@ -12473,7 +12500,7 @@
                         </a:spcAft>
                       </a:pPr>
                       <a:r>
-                        <a:rPr sz="1050" b="1" i="0">
+                        <a:rPr sz="1000" b="1" i="0">
                           <a:solidFill>
                             <a:srgbClr val="D64545"/>
                           </a:solidFill>
@@ -12500,13 +12527,13 @@
                         </a:spcAft>
                       </a:pPr>
                       <a:r>
-                        <a:rPr sz="1050" b="0" i="0">
+                        <a:rPr sz="1000" b="0" i="0">
                           <a:solidFill>
                             <a:srgbClr val="1C2733"/>
                           </a:solidFill>
                           <a:latin typeface="Arial"/>
                         </a:rPr>
-                        <a:t>Outbound queue, rate limiter, randomised delays; official WhatsApp Business API in production</a:t>
+                        <a:t>Queue, rate limiter, randomised delays; official WhatsApp Business API in production</a:t>
                       </a:r>
                     </a:p>
                   </a:txBody>
@@ -12517,7 +12544,7 @@
                   </a:tcPr>
                 </a:tc>
               </a:tr>
-              <a:tr h="356616">
+              <a:tr h="324612">
                 <a:tc>
                   <a:txBody>
                     <a:bodyPr wrap="square"/>
@@ -12529,7 +12556,7 @@
                         </a:spcAft>
                       </a:pPr>
                       <a:r>
-                        <a:rPr sz="1050" b="1" i="0">
+                        <a:rPr sz="1000" b="1" i="0">
                           <a:solidFill>
                             <a:srgbClr val="D64545"/>
                           </a:solidFill>
@@ -12556,7 +12583,7 @@
                         </a:spcAft>
                       </a:pPr>
                       <a:r>
-                        <a:rPr sz="1050" b="0" i="0">
+                        <a:rPr sz="1000" b="0" i="0">
                           <a:solidFill>
                             <a:srgbClr val="1C2733"/>
                           </a:solidFill>
@@ -12573,7 +12600,7 @@
                   </a:tcPr>
                 </a:tc>
               </a:tr>
-              <a:tr h="356616">
+              <a:tr h="324612">
                 <a:tc>
                   <a:txBody>
                     <a:bodyPr wrap="square"/>
@@ -12585,13 +12612,13 @@
                         </a:spcAft>
                       </a:pPr>
                       <a:r>
-                        <a:rPr sz="1050" b="1" i="0">
+                        <a:rPr sz="1000" b="1" i="0">
                           <a:solidFill>
                             <a:srgbClr val="D64545"/>
                           </a:solidFill>
                           <a:latin typeface="Arial"/>
                         </a:rPr>
-                        <a:t>No live telecom crowd data</a:t>
+                        <a:t>Hotels game the Demand Exchange</a:t>
                       </a:r>
                     </a:p>
                   </a:txBody>
@@ -12612,13 +12639,13 @@
                         </a:spcAft>
                       </a:pPr>
                       <a:r>
-                        <a:rPr sz="1050" b="0" i="0">
+                        <a:rPr sz="1000" b="0" i="0">
                           <a:solidFill>
                             <a:srgbClr val="1C2733"/>
                           </a:solidFill>
                           <a:latin typeface="Arial"/>
                         </a:rPr>
-                        <a:t>Anonymised H3 density counts + Poisson-simulated footfall (DPDP Act 2023)</a:t>
+                        <a:t>Bids checked against live inventory, discount caps, hotel reputation score</a:t>
                       </a:r>
                     </a:p>
                   </a:txBody>
@@ -12629,7 +12656,7 @@
                   </a:tcPr>
                 </a:tc>
               </a:tr>
-              <a:tr h="356616">
+              <a:tr h="324612">
                 <a:tc>
                   <a:txBody>
                     <a:bodyPr wrap="square"/>
@@ -12641,13 +12668,13 @@
                         </a:spcAft>
                       </a:pPr>
                       <a:r>
-                        <a:rPr sz="1050" b="1" i="0">
+                        <a:rPr sz="1000" b="1" i="0">
                           <a:solidFill>
                             <a:srgbClr val="D64545"/>
                           </a:solidFill>
                           <a:latin typeface="Arial"/>
                         </a:rPr>
-                        <a:t>Hotels resist new software</a:t>
+                        <a:t>Fake credit redemptions</a:t>
                       </a:r>
                     </a:p>
                   </a:txBody>
@@ -12668,19 +12695,75 @@
                         </a:spcAft>
                       </a:pPr>
                       <a:r>
-                        <a:rPr sz="1050" b="0" i="0">
+                        <a:rPr sz="1000" b="0" i="0">
                           <a:solidFill>
                             <a:srgbClr val="1C2733"/>
                           </a:solidFill>
                           <a:latin typeface="Arial"/>
                         </a:rPr>
-                        <a:t>Zero-friction iCal / webhook sync with existing PMS; rate tips on WhatsApp</a:t>
+                        <a:t>Two-way geo-fenced QR: tourist and vendor must be within 50 m</a:t>
                       </a:r>
                     </a:p>
                   </a:txBody>
                   <a:tcPr marL="73152" marR="73152" marT="27432" marB="27432" anchor="ctr">
                     <a:solidFill>
                       <a:srgbClr val="F3F5F8"/>
+                    </a:solidFill>
+                  </a:tcPr>
+                </a:tc>
+              </a:tr>
+              <a:tr h="324612">
+                <a:tc>
+                  <a:txBody>
+                    <a:bodyPr wrap="square"/>
+                    <a:lstStyle/>
+                    <a:p>
+                      <a:pPr algn="l">
+                        <a:spcAft>
+                          <a:spcPts val="200"/>
+                        </a:spcAft>
+                      </a:pPr>
+                      <a:r>
+                        <a:rPr sz="1000" b="1" i="0">
+                          <a:solidFill>
+                            <a:srgbClr val="D64545"/>
+                          </a:solidFill>
+                          <a:latin typeface="Arial"/>
+                        </a:rPr>
+                        <a:t>No live crowd data</a:t>
+                      </a:r>
+                    </a:p>
+                  </a:txBody>
+                  <a:tcPr marL="73152" marR="73152" marT="27432" marB="27432" anchor="ctr">
+                    <a:solidFill>
+                      <a:srgbClr val="FFFFFF"/>
+                    </a:solidFill>
+                  </a:tcPr>
+                </a:tc>
+                <a:tc>
+                  <a:txBody>
+                    <a:bodyPr wrap="square"/>
+                    <a:lstStyle/>
+                    <a:p>
+                      <a:pPr algn="l">
+                        <a:spcAft>
+                          <a:spcPts val="200"/>
+                        </a:spcAft>
+                      </a:pPr>
+                      <a:r>
+                        <a:rPr sz="1000" b="0" i="0">
+                          <a:solidFill>
+                            <a:srgbClr val="1C2733"/>
+                          </a:solidFill>
+                          <a:latin typeface="Arial"/>
+                        </a:rPr>
+                        <a:t>MSME WhatsApp pulses + anonymised H3 counts; synthetic data as backup</a:t>
+                      </a:r>
+                    </a:p>
+                  </a:txBody>
+                  <a:tcPr marL="73152" marR="73152" marT="27432" marB="27432" anchor="ctr">
+                    <a:solidFill>
+                      <a:srgbClr val="FFFFFF"/>
                     </a:solidFill>
                   </a:tcPr>
                 </a:tc>
@@ -13409,7 +13492,7 @@
                 </a:solidFill>
                 <a:latin typeface="Arial"/>
               </a:rPr>
-              <a:t>Budget-aware custom trips</a:t>
+              <a:t>Less crowded trips</a:t>
             </a:r>
           </a:p>
           <a:p>
@@ -13430,7 +13513,7 @@
                 </a:solidFill>
                 <a:latin typeface="Arial"/>
               </a:rPr>
-              <a:t>Eco-travel rewards</a:t>
+              <a:t>Credits for off-peak choices</a:t>
             </a:r>
           </a:p>
           <a:p>
@@ -13451,7 +13534,7 @@
                 </a:solidFill>
                 <a:latin typeface="Arial"/>
               </a:rPr>
-              <a:t>Offline SOS</a:t>
+              <a:t>One-booking local packages</a:t>
             </a:r>
           </a:p>
         </p:txBody>
@@ -13726,7 +13809,7 @@
                 </a:solidFill>
                 <a:latin typeface="Arial"/>
               </a:rPr>
-              <a:t>Zero-commission bookings</a:t>
+              <a:t>Own AI desk, no OTA cut</a:t>
             </a:r>
           </a:p>
           <a:p>
@@ -13747,7 +13830,7 @@
                 </a:solidFill>
                 <a:latin typeface="Arial"/>
               </a:rPr>
-              <a:t>AI rate tips on WhatsApp</a:t>
+              <a:t>Win overflow guests by bidding</a:t>
             </a:r>
           </a:p>
           <a:p>
@@ -13768,7 +13851,7 @@
                 </a:solidFill>
                 <a:latin typeface="Arial"/>
               </a:rPr>
-              <a:t>Own their guest data</a:t>
+              <a:t>AI rate tips on WhatsApp</a:t>
             </a:r>
           </a:p>
         </p:txBody>
@@ -14043,7 +14126,7 @@
                 </a:solidFill>
                 <a:latin typeface="Arial"/>
               </a:rPr>
-              <a:t>Verified digital badge</a:t>
+              <a:t>Sold inside micro-packages</a:t>
             </a:r>
           </a:p>
           <a:p>
@@ -14064,7 +14147,7 @@
                 </a:solidFill>
                 <a:latin typeface="Arial"/>
               </a:rPr>
-              <a:t>Direct tourist reach</a:t>
+              <a:t>Instant UPI split payouts</a:t>
             </a:r>
           </a:p>
           <a:p>
@@ -14085,7 +14168,7 @@
                 </a:solidFill>
                 <a:latin typeface="Arial"/>
               </a:rPr>
-              <a:t>No middlemen</a:t>
+              <a:t>Credits spent at their shops</a:t>
             </a:r>
           </a:p>
         </p:txBody>
@@ -14360,7 +14443,7 @@
                 </a:solidFill>
                 <a:latin typeface="Arial"/>
               </a:rPr>
-              <a:t>Predictive heatmaps</a:t>
+              <a:t>Overflow handled in advance</a:t>
             </a:r>
           </a:p>
           <a:p>
@@ -14381,7 +14464,7 @@
                 </a:solidFill>
                 <a:latin typeface="Arial"/>
               </a:rPr>
-              <a:t>Emergency policy switch</a:t>
+              <a:t>Live MSME crowd pulses</a:t>
             </a:r>
           </a:p>
           <a:p>
@@ -14402,7 +14485,7 @@
                 </a:solidFill>
                 <a:latin typeface="Arial"/>
               </a:rPr>
-              <a:t>Greener destinations</a:t>
+              <a:t>Emergency policy switch</a:t>
             </a:r>
           </a:p>
         </p:txBody>
@@ -14910,7 +14993,7 @@
                 </a:solidFill>
                 <a:latin typeface="Arial"/>
               </a:rPr>
-              <a:t>Spend shifts from OTAs to local economies</a:t>
+              <a:t>Credits recirculate in the local economy</a:t>
             </a:r>
           </a:p>
           <a:p>
@@ -14952,7 +15035,7 @@
                 </a:solidFill>
                 <a:latin typeface="Arial"/>
               </a:rPr>
-              <a:t>New income for guides &amp; homestays</a:t>
+              <a:t>Crowd balancing paid by hotels, not subsidies</a:t>
             </a:r>
           </a:p>
         </p:txBody>
@@ -16044,7 +16127,7 @@
         <p:spPr>
           <a:xfrm>
             <a:off x="365760" y="2121408"/>
-            <a:ext cx="5577840" cy="3566160"/>
+            <a:ext cx="5577840" cy="2834640"/>
           </a:xfrm>
           <a:prstGeom prst="rect">
             <a:avLst/>
@@ -16059,7 +16142,7 @@
           <a:p>
             <a:pPr algn="l" marL="155448" indent="-155448">
               <a:spcAft>
-                <a:spcPts val="500"/>
+                <a:spcPts val="400"/>
               </a:spcAft>
               <a:buClr>
                 <a:srgbClr val="1F3864"/>
@@ -16099,7 +16182,7 @@
           <a:p>
             <a:pPr algn="l" marL="155448" indent="-155448">
               <a:spcAft>
-                <a:spcPts val="500"/>
+                <a:spcPts val="400"/>
               </a:spcAft>
               <a:buClr>
                 <a:srgbClr val="1F3864"/>
@@ -16139,7 +16222,7 @@
           <a:p>
             <a:pPr algn="l" marL="155448" indent="-155448">
               <a:spcAft>
-                <a:spcPts val="500"/>
+                <a:spcPts val="400"/>
               </a:spcAft>
               <a:buClr>
                 <a:srgbClr val="1F3864"/>
@@ -16179,7 +16262,7 @@
           <a:p>
             <a:pPr algn="l" marL="155448" indent="-155448">
               <a:spcAft>
-                <a:spcPts val="500"/>
+                <a:spcPts val="400"/>
               </a:spcAft>
               <a:buClr>
                 <a:srgbClr val="1F3864"/>
@@ -16219,7 +16302,7 @@
           <a:p>
             <a:pPr algn="l" marL="155448" indent="-155448">
               <a:spcAft>
-                <a:spcPts val="500"/>
+                <a:spcPts val="400"/>
               </a:spcAft>
               <a:buClr>
                 <a:srgbClr val="1F3864"/>
@@ -16259,7 +16342,7 @@
           <a:p>
             <a:pPr algn="l" marL="155448" indent="-155448">
               <a:spcAft>
-                <a:spcPts val="500"/>
+                <a:spcPts val="400"/>
               </a:spcAft>
               <a:buClr>
                 <a:srgbClr val="1F3864"/>
@@ -16299,7 +16382,7 @@
           <a:p>
             <a:pPr algn="l" marL="155448" indent="-155448">
               <a:spcAft>
-                <a:spcPts val="500"/>
+                <a:spcPts val="400"/>
               </a:spcAft>
               <a:buClr>
                 <a:srgbClr val="1F3864"/>
@@ -16454,7 +16537,7 @@
         <p:spPr>
           <a:xfrm>
             <a:off x="6245352" y="2121408"/>
-            <a:ext cx="5577840" cy="3566160"/>
+            <a:ext cx="5577840" cy="2834640"/>
           </a:xfrm>
           <a:prstGeom prst="rect">
             <a:avLst/>
@@ -16469,7 +16552,7 @@
           <a:p>
             <a:pPr algn="l" marL="155448" indent="-155448">
               <a:spcAft>
-                <a:spcPts val="500"/>
+                <a:spcPts val="400"/>
               </a:spcAft>
               <a:buClr>
                 <a:srgbClr val="E87722"/>
@@ -16478,7 +16561,7 @@
               <a:buChar char="•"/>
             </a:pPr>
             <a:r>
-              <a:rPr sz="1100" b="0" i="0">
+              <a:rPr sz="1050" b="0" i="0">
                 <a:solidFill>
                   <a:srgbClr val="1C2733"/>
                 </a:solidFill>
@@ -16487,7 +16570,7 @@
               <a:t>Barua &amp; Kaiser (2024) Microservices dynamic pricing in travel: +22% revenue, 17% faster pricing</a:t>
             </a:r>
             <a:r>
-              <a:rPr sz="1100" b="0" i="0">
+              <a:rPr sz="1050" b="0" i="0">
                 <a:solidFill>
                   <a:srgbClr val="1C2733"/>
                 </a:solidFill>
@@ -16496,7 +16579,7 @@
               <a:t>  </a:t>
             </a:r>
             <a:r>
-              <a:rPr sz="1100" b="0" i="0">
+              <a:rPr sz="1050" b="0" i="0">
                 <a:solidFill>
                   <a:srgbClr val="0070C0"/>
                 </a:solidFill>
@@ -16509,7 +16592,7 @@
           <a:p>
             <a:pPr algn="l" marL="155448" indent="-155448">
               <a:spcAft>
-                <a:spcPts val="500"/>
+                <a:spcPts val="400"/>
               </a:spcAft>
               <a:buClr>
                 <a:srgbClr val="E87722"/>
@@ -16518,7 +16601,7 @@
               <a:buChar char="•"/>
             </a:pPr>
             <a:r>
-              <a:rPr sz="1100" b="0" i="0">
+              <a:rPr sz="1050" b="0" i="0">
                 <a:solidFill>
                   <a:srgbClr val="1C2733"/>
                 </a:solidFill>
@@ -16527,7 +16610,7 @@
               <a:t>Gössling &amp; Mei (2025) AI and sustainable tourism: risks &amp; opportunities for the SDGs, Current Issues in Tourism</a:t>
             </a:r>
             <a:r>
-              <a:rPr sz="1100" b="0" i="0">
+              <a:rPr sz="1050" b="0" i="0">
                 <a:solidFill>
                   <a:srgbClr val="1C2733"/>
                 </a:solidFill>
@@ -16536,7 +16619,7 @@
               <a:t>  </a:t>
             </a:r>
             <a:r>
-              <a:rPr sz="1100" b="0" i="0">
+              <a:rPr sz="1050" b="0" i="0">
                 <a:solidFill>
                   <a:srgbClr val="0070C0"/>
                 </a:solidFill>
@@ -16549,7 +16632,7 @@
           <a:p>
             <a:pPr algn="l" marL="155448" indent="-155448">
               <a:spcAft>
-                <a:spcPts val="500"/>
+                <a:spcPts val="400"/>
               </a:spcAft>
               <a:buClr>
                 <a:srgbClr val="E87722"/>
@@ -16558,16 +16641,16 @@
               <a:buChar char="•"/>
             </a:pPr>
             <a:r>
-              <a:rPr sz="1100" b="0" i="0">
+              <a:rPr sz="1050" b="0" i="0">
                 <a:solidFill>
                   <a:srgbClr val="1C2733"/>
                 </a:solidFill>
                 <a:latin typeface="Arial"/>
               </a:rPr>
-              <a:t>Sidiq et al. (2025) Role of AI in transforming smart tourism, JSEIT</a:t>
-            </a:r>
-            <a:r>
-              <a:rPr sz="1100" b="0" i="0">
+              <a:t>Vickrey (1961) Counterspeculation, auctions &amp; sealed tenders, J. of Finance (Demand Exchange)</a:t>
+            </a:r>
+            <a:r>
+              <a:rPr sz="1050" b="0" i="0">
                 <a:solidFill>
                   <a:srgbClr val="1C2733"/>
                 </a:solidFill>
@@ -16576,20 +16659,20 @@
               <a:t>  </a:t>
             </a:r>
             <a:r>
-              <a:rPr sz="1100" b="0" i="0">
+              <a:rPr sz="1050" b="0" i="0">
                 <a:solidFill>
                   <a:srgbClr val="0070C0"/>
                 </a:solidFill>
                 <a:latin typeface="Arial"/>
                 <a:hlinkClick r:id="rId15"/>
               </a:rPr>
-              <a:t>doi:10.31764/jseit.v5i2.30705</a:t>
+              <a:t>doi:10.1111/j.1540-6261.1961.tb02789.x</a:t>
             </a:r>
           </a:p>
           <a:p>
             <a:pPr algn="l" marL="155448" indent="-155448">
               <a:spcAft>
-                <a:spcPts val="500"/>
+                <a:spcPts val="400"/>
               </a:spcAft>
               <a:buClr>
                 <a:srgbClr val="E87722"/>
@@ -16598,38 +16681,19 @@
               <a:buChar char="•"/>
             </a:pPr>
             <a:r>
-              <a:rPr sz="1100" b="0" i="0">
+              <a:rPr sz="1050" b="0" i="0">
                 <a:solidFill>
                   <a:srgbClr val="1C2733"/>
                 </a:solidFill>
                 <a:latin typeface="Arial"/>
               </a:rPr>
-              <a:t>Chen &amp; Guestrin (2016) XGBoost: a scalable tree boosting system, KDD</a:t>
-            </a:r>
-            <a:r>
-              <a:rPr sz="1100" b="0" i="0">
-                <a:solidFill>
-                  <a:srgbClr val="1C2733"/>
-                </a:solidFill>
-                <a:latin typeface="Arial"/>
-              </a:rPr>
-              <a:t>  </a:t>
-            </a:r>
-            <a:r>
-              <a:rPr sz="1100" b="0" i="0">
-                <a:solidFill>
-                  <a:srgbClr val="0070C0"/>
-                </a:solidFill>
-                <a:latin typeface="Arial"/>
-                <a:hlinkClick r:id="rId16"/>
-              </a:rPr>
-              <a:t>doi:10.1145/2939672.2939785</a:t>
+              <a:t>Cifuentes (1992) Tourism carrying-capacity method, CATIE (Capacity Guard)</a:t>
             </a:r>
           </a:p>
           <a:p>
             <a:pPr algn="l" marL="155448" indent="-155448">
               <a:spcAft>
-                <a:spcPts val="500"/>
+                <a:spcPts val="400"/>
               </a:spcAft>
               <a:buClr>
                 <a:srgbClr val="E87722"/>
@@ -16638,16 +16702,56 @@
               <a:buChar char="•"/>
             </a:pPr>
             <a:r>
-              <a:rPr sz="1100" b="0" i="0">
+              <a:rPr sz="1050" b="0" i="0">
                 <a:solidFill>
                   <a:srgbClr val="1C2733"/>
                 </a:solidFill>
                 <a:latin typeface="Arial"/>
               </a:rPr>
+              <a:t>Chen &amp; Guestrin (2016) XGBoost: a scalable tree boosting system, KDD</a:t>
+            </a:r>
+            <a:r>
+              <a:rPr sz="1050" b="0" i="0">
+                <a:solidFill>
+                  <a:srgbClr val="1C2733"/>
+                </a:solidFill>
+                <a:latin typeface="Arial"/>
+              </a:rPr>
+              <a:t>  </a:t>
+            </a:r>
+            <a:r>
+              <a:rPr sz="1050" b="0" i="0">
+                <a:solidFill>
+                  <a:srgbClr val="0070C0"/>
+                </a:solidFill>
+                <a:latin typeface="Arial"/>
+                <a:hlinkClick r:id="rId16"/>
+              </a:rPr>
+              <a:t>doi:10.1145/2939672.2939785</a:t>
+            </a:r>
+          </a:p>
+          <a:p>
+            <a:pPr algn="l" marL="155448" indent="-155448">
+              <a:spcAft>
+                <a:spcPts val="400"/>
+              </a:spcAft>
+              <a:buClr>
+                <a:srgbClr val="E87722"/>
+              </a:buClr>
+              <a:buFont typeface="Arial"/>
+              <a:buChar char="•"/>
+            </a:pPr>
+            <a:r>
+              <a:rPr sz="1050" b="0" i="0">
+                <a:solidFill>
+                  <a:srgbClr val="1C2733"/>
+                </a:solidFill>
+                <a:latin typeface="Arial"/>
+              </a:rPr>
               <a:t>Taylor &amp; Letham (2018) Forecasting at scale (Prophet), The American Statistician</a:t>
             </a:r>
             <a:r>
-              <a:rPr sz="1100" b="0" i="0">
+              <a:rPr sz="1050" b="0" i="0">
                 <a:solidFill>
                   <a:srgbClr val="1C2733"/>
                 </a:solidFill>
@@ -16656,7 +16760,7 @@
               <a:t>  </a:t>
             </a:r>
             <a:r>
-              <a:rPr sz="1100" b="0" i="0">
+              <a:rPr sz="1050" b="0" i="0">
                 <a:solidFill>
                   <a:srgbClr val="0070C0"/>
                 </a:solidFill>
@@ -16799,7 +16903,16 @@
                 </a:solidFill>
                 <a:latin typeface="Arial"/>
               </a:rPr>
-              <a:t>MakeMyTrip, Booking.com, EaseMyTrip (OTAs, 15–30% commission, no crowd balancing) · Mindtrip.ai (AI planner, no hotel/PMS link) · Airbnb Experiences · state tourism apps (information only).</a:t>
+              <a:t>OTAs (MakeMyTrip, Booking.com: 15–30% commission) · AI planners (Mindtrip.ai: no hotel link) · state e-pass systems (cap entry, don't redirect). </a:t>
+            </a:r>
+            <a:r>
+              <a:rPr sz="1050" b="1" i="0">
+                <a:solidFill>
+                  <a:srgbClr val="E87722"/>
+                </a:solidFill>
+                <a:latin typeface="Arial"/>
+              </a:rPr>
+              <a:t>None of these offers a hotel-bid Demand Exchange or a per-hotel WhatsApp AI desk.</a:t>
             </a:r>
           </a:p>
         </p:txBody>

</xml_diff>